<commit_message>
Record the 21 October instructor demonstration in the Sprint 1 report
The running build was demonstrated on the deployed Azure environment on
21 October and the instructor confirmed the demonstrated scope, so the
cloud demo is no longer an open Sprint 2 item. The report records it as a
dated stakeholder event, closes the matching Sprint 0 improvement action,
and keeps the scope-baseline acknowledgement open because the
confirmation was verbal. The deck's milestone table and Sprint 2 list
follow the same correction.

Co-Authored-By: Claude Opus 5 <noreply@anthropic.com>
</commit_message>
<xml_diff>
--- a/project-plan/StatusReports2/DealerOps Status Report 2 - Sprint 1 - Group 2.pptx
+++ b/project-plan/StatusReports2/DealerOps Status Report 2 - Sprint 1 - Group 2.pptx
@@ -123,19 +123,19 @@
   <p:extLst>
     <p:ext uri="{521415D9-36F7-43E2-AB2F-B90AF26B5E84}">
       <p14:sectionLst xmlns:p14="http://schemas.microsoft.com/office/powerpoint/2010/main">
-        <p14:section name="Opening" id="{0e9fb50d-4eb3-4b4e-a9b2-cf73c86edc55}">
+        <p14:section name="Opening" id="{f8a41403-eb95-721d-05b1-a36ae22f5239}">
           <p14:sldIdLst>
             <p14:sldId id="256"/>
           </p14:sldIdLst>
         </p14:section>
-        <p14:section name="Progress" id="{fd7ca6ea-5f07-fad6-5723-4a771ce95abd}">
+        <p14:section name="Progress" id="{d7655ece-cc28-67ff-f519-315f6a98e484}">
           <p14:sldIdLst>
             <p14:sldId id="257"/>
             <p14:sldId id="258"/>
             <p14:sldId id="259"/>
           </p14:sldIdLst>
         </p14:section>
-        <p14:section name="Architecture" id="{839973b6-a850-90ea-8c17-02c94060646d}">
+        <p14:section name="Architecture" id="{9160caaf-f154-9279-7731-8ef3d0548aae}">
           <p14:sldIdLst>
             <p14:sldId id="260"/>
             <p14:sldId id="261"/>
@@ -146,14 +146,14 @@
             <p14:sldId id="266"/>
           </p14:sldIdLst>
         </p14:section>
-        <p14:section name="Milestones" id="{ddd73604-f79d-cf47-8c02-f5875b11a6e8}">
+        <p14:section name="Milestones" id="{a956a9dd-2e78-dc99-2f58-24ee9515da32}">
           <p14:sldIdLst>
             <p14:sldId id="267"/>
             <p14:sldId id="268"/>
             <p14:sldId id="269"/>
           </p14:sldIdLst>
         </p14:section>
-        <p14:section name="Demo and next" id="{ad5347ad-e4c1-98a4-47a3-0cafc65c56ca}">
+        <p14:section name="Demo and next" id="{f855f8f5-2c19-18d3-ec03-2d121ffb1918}">
           <p14:sldIdLst>
             <p14:sldId id="270"/>
             <p14:sldId id="271"/>
@@ -7472,7 +7472,7 @@
                             <a:srgbClr val="0F1F2E"/>
                           </a:solidFill>
                         </a:rPr>
-                        <a:t>Live two-dealership demo on the deployed environment</a:t>
+                        <a:t>Live demo on the deployed environment</a:t>
                       </a:r>
                       <a:endParaRPr lang="en-US" sz="1100" dirty="0"/>
                     </a:p>
@@ -7594,7 +7594,7 @@
                             <a:srgbClr val="0F1F2E"/>
                           </a:solidFill>
                         </a:rPr>
-                        <a:t>Rehearsal scheduled before the class demo</a:t>
+                        <a:t>Done early — demonstrated to the instructor on 21 October, who confirmed the demonstrated scope</a:t>
                       </a:r>
                       <a:endParaRPr lang="en-US" sz="1100" dirty="0"/>
                     </a:p>
@@ -8377,7 +8377,7 @@
                   <a:schemeClr val="accent5"/>
                 </a:solidFill>
               </a:rPr>
-              <a:t>Six acceptance scripts, run on two dealerships with real demo data. Feature code is complete, so this is a finished build rather than a partial prototype.</a:t>
+              <a:t>Six acceptance scripts, run on two dealerships with real demo data. The build already ran on the deployed Azure environment for the instructor on 21 October; this is a finished build, not a partial prototype.</a:t>
             </a:r>
             <a:endParaRPr lang="en-US" sz="1350" dirty="0"/>
           </a:p>
@@ -9949,7 +9949,7 @@
                   <a:srgbClr val="FFFFFF"/>
                 </a:solidFill>
               </a:rPr>
-              <a:t>Research log and AI log published; scope baseline and NN-05 confirmed.</a:t>
+              <a:t>Research log and AI log published on the team site, and the research log actually filled.</a:t>
             </a:r>
             <a:endParaRPr lang="en-US" sz="1150" dirty="0"/>
           </a:p>
@@ -9970,7 +9970,7 @@
                   <a:srgbClr val="FFFFFF"/>
                 </a:solidFill>
               </a:rPr>
-              <a:t>Live demo rehearsed on the deployed environment with the two-dealership data set.</a:t>
+              <a:t>Written instructor acknowledgement of the scope baseline and the NN-05 hosting decision; the 21 October confirmation was verbal.</a:t>
             </a:r>
             <a:endParaRPr lang="en-US" sz="1150" dirty="0"/>
           </a:p>

</xml_diff>